<commit_message>
Remove presenter notes from the presentation deck
</commit_message>
<xml_diff>
--- a/reports/AAI-540_Group2_Deliverable-2_Presentation.pptx
+++ b/reports/AAI-540_Group2_Deliverable-2_Presentation.pptx
@@ -6,17 +6,17 @@
   </p:sldMasterIdLst>
   <p:sldIdLst>
     <p:sldId id="256" r:id="rId7"/>
-    <p:sldId id="257" r:id="rId9"/>
-    <p:sldId id="258" r:id="rId10"/>
-    <p:sldId id="259" r:id="rId11"/>
-    <p:sldId id="260" r:id="rId12"/>
-    <p:sldId id="261" r:id="rId13"/>
-    <p:sldId id="262" r:id="rId14"/>
-    <p:sldId id="263" r:id="rId15"/>
-    <p:sldId id="264" r:id="rId16"/>
-    <p:sldId id="265" r:id="rId17"/>
-    <p:sldId id="266" r:id="rId18"/>
-    <p:sldId id="267" r:id="rId19"/>
+    <p:sldId id="257" r:id="rId8"/>
+    <p:sldId id="258" r:id="rId9"/>
+    <p:sldId id="259" r:id="rId10"/>
+    <p:sldId id="260" r:id="rId11"/>
+    <p:sldId id="261" r:id="rId12"/>
+    <p:sldId id="262" r:id="rId13"/>
+    <p:sldId id="263" r:id="rId14"/>
+    <p:sldId id="264" r:id="rId15"/>
+    <p:sldId id="265" r:id="rId16"/>
+    <p:sldId id="266" r:id="rId17"/>
+    <p:sldId id="267" r:id="rId18"/>
   </p:sldIdLst>
   <p:sldSz cx="12191695" cy="6858000" type="screen4x3"/>
   <p:notesSz cx="6858000" cy="9144000"/>
@@ -116,1268 +116,6 @@
     </a:lvl9pPr>
   </p:defaultTextStyle>
 </p:presentation>
-</file>
-
-<file path=ppt/notesMasters/notesMaster1.xml><?xml version="1.0" encoding="utf-8"?>
-<p:notesMaster xmlns:a="http://schemas.openxmlformats.org/drawingml/2006/main" xmlns:p="http://schemas.openxmlformats.org/presentationml/2006/main" xmlns:r="http://schemas.openxmlformats.org/officeDocument/2006/relationships">
-  <p:cSld>
-    <p:bg>
-      <p:bgRef idx="1001">
-        <a:schemeClr val="bg1"/>
-      </p:bgRef>
-    </p:bg>
-    <p:spTree>
-      <p:nvGrpSpPr>
-        <p:cNvPr id="1" name=""/>
-        <p:cNvGrpSpPr/>
-        <p:nvPr/>
-      </p:nvGrpSpPr>
-      <p:grpSpPr>
-        <a:xfrm>
-          <a:off x="0" y="0"/>
-          <a:ext cx="0" cy="0"/>
-          <a:chOff x="0" y="0"/>
-          <a:chExt cx="0" cy="0"/>
-        </a:xfrm>
-      </p:grpSpPr>
-      <p:sp>
-        <p:nvSpPr>
-          <p:cNvPr id="2" name="Header Placeholder 1"/>
-          <p:cNvSpPr>
-            <a:spLocks noGrp="1"/>
-          </p:cNvSpPr>
-          <p:nvPr>
-            <p:ph type="hdr" sz="quarter"/>
-          </p:nvPr>
-        </p:nvSpPr>
-        <p:spPr>
-          <a:xfrm>
-            <a:off x="0" y="0"/>
-            <a:ext cx="2971800" cy="457200"/>
-          </a:xfrm>
-          <a:prstGeom prst="rect">
-            <a:avLst/>
-          </a:prstGeom>
-        </p:spPr>
-        <p:txBody>
-          <a:bodyPr vert="horz" lIns="91440" tIns="45720" rIns="91440" bIns="45720" rtlCol="0"/>
-          <a:lstStyle>
-            <a:lvl1pPr algn="l">
-              <a:defRPr sz="1200"/>
-            </a:lvl1pPr>
-          </a:lstStyle>
-          <a:p>
-            <a:endParaRPr lang="en-US"/>
-          </a:p>
-        </p:txBody>
-      </p:sp>
-      <p:sp>
-        <p:nvSpPr>
-          <p:cNvPr id="3" name="Date Placeholder 2"/>
-          <p:cNvSpPr>
-            <a:spLocks noGrp="1"/>
-          </p:cNvSpPr>
-          <p:nvPr>
-            <p:ph type="dt" idx="1"/>
-          </p:nvPr>
-        </p:nvSpPr>
-        <p:spPr>
-          <a:xfrm>
-            <a:off x="3884613" y="0"/>
-            <a:ext cx="2971800" cy="457200"/>
-          </a:xfrm>
-          <a:prstGeom prst="rect">
-            <a:avLst/>
-          </a:prstGeom>
-        </p:spPr>
-        <p:txBody>
-          <a:bodyPr vert="horz" lIns="91440" tIns="45720" rIns="91440" bIns="45720" rtlCol="0"/>
-          <a:lstStyle>
-            <a:lvl1pPr algn="r">
-              <a:defRPr sz="1200"/>
-            </a:lvl1pPr>
-          </a:lstStyle>
-          <a:p>
-            <a:fld id="{0F89C1C7-3DCD-1040-A9CF-14679D8B5DDD}" type="datetimeFigureOut">
-              <a:rPr lang="en-US" smtClean="0"/>
-              <a:t>10/17/16</a:t>
-            </a:fld>
-            <a:endParaRPr lang="en-US"/>
-          </a:p>
-        </p:txBody>
-      </p:sp>
-      <p:sp>
-        <p:nvSpPr>
-          <p:cNvPr id="4" name="Slide Image Placeholder 3"/>
-          <p:cNvSpPr>
-            <a:spLocks noGrp="1" noRot="1" noChangeAspect="1"/>
-          </p:cNvSpPr>
-          <p:nvPr>
-            <p:ph type="sldImg" idx="2"/>
-          </p:nvPr>
-        </p:nvSpPr>
-        <p:spPr>
-          <a:xfrm>
-            <a:off x="1143000" y="685800"/>
-            <a:ext cx="4572000" cy="3429000"/>
-          </a:xfrm>
-          <a:prstGeom prst="rect">
-            <a:avLst/>
-          </a:prstGeom>
-          <a:noFill/>
-          <a:ln w="12700">
-            <a:solidFill>
-              <a:prstClr val="black"/>
-            </a:solidFill>
-          </a:ln>
-        </p:spPr>
-        <p:txBody>
-          <a:bodyPr vert="horz" lIns="91440" tIns="45720" rIns="91440" bIns="45720" rtlCol="0" anchor="ctr"/>
-          <a:lstStyle/>
-          <a:p>
-            <a:endParaRPr lang="en-US"/>
-          </a:p>
-        </p:txBody>
-      </p:sp>
-      <p:sp>
-        <p:nvSpPr>
-          <p:cNvPr id="5" name="Notes Placeholder 4"/>
-          <p:cNvSpPr>
-            <a:spLocks noGrp="1"/>
-          </p:cNvSpPr>
-          <p:nvPr>
-            <p:ph type="body" sz="quarter" idx="3"/>
-          </p:nvPr>
-        </p:nvSpPr>
-        <p:spPr>
-          <a:xfrm>
-            <a:off x="685800" y="4343400"/>
-            <a:ext cx="5486400" cy="4114800"/>
-          </a:xfrm>
-          <a:prstGeom prst="rect">
-            <a:avLst/>
-          </a:prstGeom>
-        </p:spPr>
-        <p:txBody>
-          <a:bodyPr vert="horz" lIns="91440" tIns="45720" rIns="91440" bIns="45720" rtlCol="0"/>
-          <a:lstStyle/>
-          <a:p>
-            <a:pPr lvl="0"/>
-            <a:r>
-              <a:rPr lang="en-US" smtClean="0"/>
-              <a:t>Click to edit Master text styles</a:t>
-            </a:r>
-          </a:p>
-          <a:p>
-            <a:pPr lvl="1"/>
-            <a:r>
-              <a:rPr lang="en-US" smtClean="0"/>
-              <a:t>Second level</a:t>
-            </a:r>
-          </a:p>
-          <a:p>
-            <a:pPr lvl="2"/>
-            <a:r>
-              <a:rPr lang="en-US" smtClean="0"/>
-              <a:t>Third level</a:t>
-            </a:r>
-          </a:p>
-          <a:p>
-            <a:pPr lvl="3"/>
-            <a:r>
-              <a:rPr lang="en-US" smtClean="0"/>
-              <a:t>Fourth level</a:t>
-            </a:r>
-          </a:p>
-          <a:p>
-            <a:pPr lvl="4"/>
-            <a:r>
-              <a:rPr lang="en-US" smtClean="0"/>
-              <a:t>Fifth level</a:t>
-            </a:r>
-            <a:endParaRPr lang="en-US"/>
-          </a:p>
-        </p:txBody>
-      </p:sp>
-      <p:sp>
-        <p:nvSpPr>
-          <p:cNvPr id="6" name="Footer Placeholder 5"/>
-          <p:cNvSpPr>
-            <a:spLocks noGrp="1"/>
-          </p:cNvSpPr>
-          <p:nvPr>
-            <p:ph type="ftr" sz="quarter" idx="4"/>
-          </p:nvPr>
-        </p:nvSpPr>
-        <p:spPr>
-          <a:xfrm>
-            <a:off x="0" y="8685213"/>
-            <a:ext cx="2971800" cy="457200"/>
-          </a:xfrm>
-          <a:prstGeom prst="rect">
-            <a:avLst/>
-          </a:prstGeom>
-        </p:spPr>
-        <p:txBody>
-          <a:bodyPr vert="horz" lIns="91440" tIns="45720" rIns="91440" bIns="45720" rtlCol="0" anchor="b"/>
-          <a:lstStyle>
-            <a:lvl1pPr algn="l">
-              <a:defRPr sz="1200"/>
-            </a:lvl1pPr>
-          </a:lstStyle>
-          <a:p>
-            <a:endParaRPr lang="en-US"/>
-          </a:p>
-        </p:txBody>
-      </p:sp>
-      <p:sp>
-        <p:nvSpPr>
-          <p:cNvPr id="7" name="Slide Number Placeholder 6"/>
-          <p:cNvSpPr>
-            <a:spLocks noGrp="1"/>
-          </p:cNvSpPr>
-          <p:nvPr>
-            <p:ph type="sldNum" sz="quarter" idx="5"/>
-          </p:nvPr>
-        </p:nvSpPr>
-        <p:spPr>
-          <a:xfrm>
-            <a:off x="3884613" y="8685213"/>
-            <a:ext cx="2971800" cy="457200"/>
-          </a:xfrm>
-          <a:prstGeom prst="rect">
-            <a:avLst/>
-          </a:prstGeom>
-        </p:spPr>
-        <p:txBody>
-          <a:bodyPr vert="horz" lIns="91440" tIns="45720" rIns="91440" bIns="45720" rtlCol="0" anchor="b"/>
-          <a:lstStyle>
-            <a:lvl1pPr algn="r">
-              <a:defRPr sz="1200"/>
-            </a:lvl1pPr>
-          </a:lstStyle>
-          <a:p>
-            <a:fld id="{BB5E49A5-4136-284D-997B-48E1D791AD67}" type="slidenum">
-              <a:rPr lang="en-US" smtClean="0"/>
-              <a:t>‹#›</a:t>
-            </a:fld>
-            <a:endParaRPr lang="en-US"/>
-          </a:p>
-        </p:txBody>
-      </p:sp>
-    </p:spTree>
-    <p:extLst>
-      <p:ext uri="{BB962C8B-B14F-4D97-AF65-F5344CB8AC3E}">
-        <p14:creationId xmlns:p14="http://schemas.microsoft.com/office/powerpoint/2010/main" val="2623252185"/>
-      </p:ext>
-    </p:extLst>
-  </p:cSld>
-  <p:clrMap bg1="lt1" tx1="dk1" bg2="lt2" tx2="dk2" accent1="accent1" accent2="accent2" accent3="accent3" accent4="accent4" accent5="accent5" accent6="accent6" hlink="hlink" folHlink="folHlink"/>
-  <p:notesStyle>
-    <a:lvl1pPr marL="0" algn="l" defTabSz="457200" rtl="0" eaLnBrk="1" latinLnBrk="0" hangingPunct="1">
-      <a:defRPr sz="1200" kern="1200">
-        <a:solidFill>
-          <a:schemeClr val="tx1"/>
-        </a:solidFill>
-        <a:latin typeface="+mn-lt"/>
-        <a:ea typeface="+mn-ea"/>
-        <a:cs typeface="+mn-cs"/>
-      </a:defRPr>
-    </a:lvl1pPr>
-    <a:lvl2pPr marL="457200" algn="l" defTabSz="457200" rtl="0" eaLnBrk="1" latinLnBrk="0" hangingPunct="1">
-      <a:defRPr sz="1200" kern="1200">
-        <a:solidFill>
-          <a:schemeClr val="tx1"/>
-        </a:solidFill>
-        <a:latin typeface="+mn-lt"/>
-        <a:ea typeface="+mn-ea"/>
-        <a:cs typeface="+mn-cs"/>
-      </a:defRPr>
-    </a:lvl2pPr>
-    <a:lvl3pPr marL="914400" algn="l" defTabSz="457200" rtl="0" eaLnBrk="1" latinLnBrk="0" hangingPunct="1">
-      <a:defRPr sz="1200" kern="1200">
-        <a:solidFill>
-          <a:schemeClr val="tx1"/>
-        </a:solidFill>
-        <a:latin typeface="+mn-lt"/>
-        <a:ea typeface="+mn-ea"/>
-        <a:cs typeface="+mn-cs"/>
-      </a:defRPr>
-    </a:lvl3pPr>
-    <a:lvl4pPr marL="1371600" algn="l" defTabSz="457200" rtl="0" eaLnBrk="1" latinLnBrk="0" hangingPunct="1">
-      <a:defRPr sz="1200" kern="1200">
-        <a:solidFill>
-          <a:schemeClr val="tx1"/>
-        </a:solidFill>
-        <a:latin typeface="+mn-lt"/>
-        <a:ea typeface="+mn-ea"/>
-        <a:cs typeface="+mn-cs"/>
-      </a:defRPr>
-    </a:lvl4pPr>
-    <a:lvl5pPr marL="1828800" algn="l" defTabSz="457200" rtl="0" eaLnBrk="1" latinLnBrk="0" hangingPunct="1">
-      <a:defRPr sz="1200" kern="1200">
-        <a:solidFill>
-          <a:schemeClr val="tx1"/>
-        </a:solidFill>
-        <a:latin typeface="+mn-lt"/>
-        <a:ea typeface="+mn-ea"/>
-        <a:cs typeface="+mn-cs"/>
-      </a:defRPr>
-    </a:lvl5pPr>
-    <a:lvl6pPr marL="2286000" algn="l" defTabSz="457200" rtl="0" eaLnBrk="1" latinLnBrk="0" hangingPunct="1">
-      <a:defRPr sz="1200" kern="1200">
-        <a:solidFill>
-          <a:schemeClr val="tx1"/>
-        </a:solidFill>
-        <a:latin typeface="+mn-lt"/>
-        <a:ea typeface="+mn-ea"/>
-        <a:cs typeface="+mn-cs"/>
-      </a:defRPr>
-    </a:lvl6pPr>
-    <a:lvl7pPr marL="2743200" algn="l" defTabSz="457200" rtl="0" eaLnBrk="1" latinLnBrk="0" hangingPunct="1">
-      <a:defRPr sz="1200" kern="1200">
-        <a:solidFill>
-          <a:schemeClr val="tx1"/>
-        </a:solidFill>
-        <a:latin typeface="+mn-lt"/>
-        <a:ea typeface="+mn-ea"/>
-        <a:cs typeface="+mn-cs"/>
-      </a:defRPr>
-    </a:lvl7pPr>
-    <a:lvl8pPr marL="3200400" algn="l" defTabSz="457200" rtl="0" eaLnBrk="1" latinLnBrk="0" hangingPunct="1">
-      <a:defRPr sz="1200" kern="1200">
-        <a:solidFill>
-          <a:schemeClr val="tx1"/>
-        </a:solidFill>
-        <a:latin typeface="+mn-lt"/>
-        <a:ea typeface="+mn-ea"/>
-        <a:cs typeface="+mn-cs"/>
-      </a:defRPr>
-    </a:lvl8pPr>
-    <a:lvl9pPr marL="3657600" algn="l" defTabSz="457200" rtl="0" eaLnBrk="1" latinLnBrk="0" hangingPunct="1">
-      <a:defRPr sz="1200" kern="1200">
-        <a:solidFill>
-          <a:schemeClr val="tx1"/>
-        </a:solidFill>
-        <a:latin typeface="+mn-lt"/>
-        <a:ea typeface="+mn-ea"/>
-        <a:cs typeface="+mn-cs"/>
-      </a:defRPr>
-    </a:lvl9pPr>
-  </p:notesStyle>
-</p:notesMaster>
-</file>
-
-<file path=ppt/notesSlides/notesSlide1.xml><?xml version="1.0" encoding="utf-8"?>
-<p:notes xmlns:a="http://schemas.openxmlformats.org/drawingml/2006/main" xmlns:p="http://schemas.openxmlformats.org/presentationml/2006/main" xmlns:r="http://schemas.openxmlformats.org/officeDocument/2006/relationships">
-  <p:cSld>
-    <p:spTree>
-      <p:nvGrpSpPr>
-        <p:cNvPr id="1" name=""/>
-        <p:cNvGrpSpPr/>
-        <p:nvPr/>
-      </p:nvGrpSpPr>
-      <p:grpSpPr>
-        <a:xfrm>
-          <a:off x="0" y="0"/>
-          <a:ext cx="0" cy="0"/>
-          <a:chOff x="0" y="0"/>
-          <a:chExt cx="0" cy="0"/>
-        </a:xfrm>
-      </p:grpSpPr>
-      <p:sp>
-        <p:nvSpPr>
-          <p:cNvPr id="2" name="Slide Image Placeholder 1"/>
-          <p:cNvSpPr>
-            <a:spLocks noGrp="1"/>
-          </p:cNvSpPr>
-          <p:nvPr>
-            <p:ph type="sldImg" idx="2"/>
-          </p:nvPr>
-        </p:nvSpPr>
-        <p:spPr/>
-      </p:sp>
-      <p:sp>
-        <p:nvSpPr>
-          <p:cNvPr id="3" name="Notes Placeholder 2"/>
-          <p:cNvSpPr>
-            <a:spLocks noGrp="1"/>
-          </p:cNvSpPr>
-          <p:nvPr>
-            <p:ph type="body" idx="3" sz="quarter"/>
-          </p:nvPr>
-        </p:nvSpPr>
-        <p:spPr/>
-        <p:txBody>
-          <a:bodyPr/>
-          <a:lstStyle/>
-          <a:p>
-            <a:r>
-              <a:t>[PRESENTER: Ashis Das (intro, 0:00-0:45)]</a:t>
-            </a:r>
-          </a:p>
-          <a:p/>
-          <a:p>
-            <a:r>
-              <a:t>Welcome. We are Group 2. Over the next ~12 minutes we will walk through our Heart-Disease Risk Screening ML system built on AWS SageMaker. I'll cover the business case and architecture, then Hanmant will present the feature store, infrastructure monitoring and the CI/CD pipeline, and Ram will present the monitoring, the model registry and batch inference. Each of us presents an equal portion. Let's start with the business problem.</a:t>
-            </a:r>
-          </a:p>
-        </p:txBody>
-      </p:sp>
-      <p:sp>
-        <p:nvSpPr>
-          <p:cNvPr id="4" name="Slide Number Placeholder 3"/>
-          <p:cNvSpPr>
-            <a:spLocks noGrp="1"/>
-          </p:cNvSpPr>
-          <p:nvPr>
-            <p:ph type="sldNum" idx="5" sz="quarter"/>
-          </p:nvPr>
-        </p:nvSpPr>
-        <p:spPr/>
-      </p:sp>
-    </p:spTree>
-  </p:cSld>
-  <p:clrMapOvr>
-    <a:masterClrMapping/>
-  </p:clrMapOvr>
-</p:notes>
-</file>
-
-<file path=ppt/notesSlides/notesSlide10.xml><?xml version="1.0" encoding="utf-8"?>
-<p:notes xmlns:a="http://schemas.openxmlformats.org/drawingml/2006/main" xmlns:p="http://schemas.openxmlformats.org/presentationml/2006/main" xmlns:r="http://schemas.openxmlformats.org/officeDocument/2006/relationships">
-  <p:cSld>
-    <p:spTree>
-      <p:nvGrpSpPr>
-        <p:cNvPr id="1" name=""/>
-        <p:cNvGrpSpPr/>
-        <p:nvPr/>
-      </p:nvGrpSpPr>
-      <p:grpSpPr>
-        <a:xfrm>
-          <a:off x="0" y="0"/>
-          <a:ext cx="0" cy="0"/>
-          <a:chOff x="0" y="0"/>
-          <a:chExt cx="0" cy="0"/>
-        </a:xfrm>
-      </p:grpSpPr>
-      <p:sp>
-        <p:nvSpPr>
-          <p:cNvPr id="2" name="Slide Image Placeholder 1"/>
-          <p:cNvSpPr>
-            <a:spLocks noGrp="1"/>
-          </p:cNvSpPr>
-          <p:nvPr>
-            <p:ph type="sldImg" idx="2"/>
-          </p:nvPr>
-        </p:nvSpPr>
-        <p:spPr/>
-      </p:sp>
-      <p:sp>
-        <p:nvSpPr>
-          <p:cNvPr id="3" name="Notes Placeholder 2"/>
-          <p:cNvSpPr>
-            <a:spLocks noGrp="1"/>
-          </p:cNvSpPr>
-          <p:nvPr>
-            <p:ph type="body" idx="3" sz="quarter"/>
-          </p:nvPr>
-        </p:nvSpPr>
-        <p:spPr/>
-        <p:txBody>
-          <a:bodyPr/>
-          <a:lstStyle/>
-          <a:p>
-            <a:r>
-              <a:t>[PRESENTER: Ram Prasanth G (10:15-11:30)]</a:t>
-            </a:r>
-          </a:p>
-          <a:p/>
-          <a:p>
-            <a:r>
-              <a:t>Finally, the system producing value. In the SageMaker design this is a Batch Transform job; here we demonstrate the equivalent with our local batch-inference script (src/batch_inference.py). It scores the entire 2023 cohort and writes an output file where every person gets a heart-disease risk probability. Applying our operating threshold turns those probabilities into a ranked outreach list, so the health team contacts the highest-risk people first. The confusion matrix on the right puts this in context: at our chosen operating point we correctly catch about 82 percent of true cases. The job runs on a modest CPU instance and scales to hundreds of thousands of rows cheaply. And to be clear — this prioritises people for screening; it is not a medical diagnosis.</a:t>
-            </a:r>
-          </a:p>
-        </p:txBody>
-      </p:sp>
-      <p:sp>
-        <p:nvSpPr>
-          <p:cNvPr id="4" name="Slide Number Placeholder 3"/>
-          <p:cNvSpPr>
-            <a:spLocks noGrp="1"/>
-          </p:cNvSpPr>
-          <p:nvPr>
-            <p:ph type="sldNum" idx="5" sz="quarter"/>
-          </p:nvPr>
-        </p:nvSpPr>
-        <p:spPr/>
-      </p:sp>
-    </p:spTree>
-  </p:cSld>
-  <p:clrMapOvr>
-    <a:masterClrMapping/>
-  </p:clrMapOvr>
-</p:notes>
-</file>
-
-<file path=ppt/notesSlides/notesSlide11.xml><?xml version="1.0" encoding="utf-8"?>
-<p:notes xmlns:a="http://schemas.openxmlformats.org/drawingml/2006/main" xmlns:p="http://schemas.openxmlformats.org/presentationml/2006/main" xmlns:r="http://schemas.openxmlformats.org/officeDocument/2006/relationships">
-  <p:cSld>
-    <p:spTree>
-      <p:nvGrpSpPr>
-        <p:cNvPr id="1" name=""/>
-        <p:cNvGrpSpPr/>
-        <p:nvPr/>
-      </p:nvGrpSpPr>
-      <p:grpSpPr>
-        <a:xfrm>
-          <a:off x="0" y="0"/>
-          <a:ext cx="0" cy="0"/>
-          <a:chOff x="0" y="0"/>
-          <a:chExt cx="0" cy="0"/>
-        </a:xfrm>
-      </p:grpSpPr>
-      <p:sp>
-        <p:nvSpPr>
-          <p:cNvPr id="2" name="Slide Image Placeholder 1"/>
-          <p:cNvSpPr>
-            <a:spLocks noGrp="1"/>
-          </p:cNvSpPr>
-          <p:nvPr>
-            <p:ph type="sldImg" idx="2"/>
-          </p:nvPr>
-        </p:nvSpPr>
-        <p:spPr/>
-      </p:sp>
-      <p:sp>
-        <p:nvSpPr>
-          <p:cNvPr id="3" name="Notes Placeholder 2"/>
-          <p:cNvSpPr>
-            <a:spLocks noGrp="1"/>
-          </p:cNvSpPr>
-          <p:nvPr>
-            <p:ph type="body" idx="3" sz="quarter"/>
-          </p:nvPr>
-        </p:nvSpPr>
-        <p:spPr/>
-        <p:txBody>
-          <a:bodyPr/>
-          <a:lstStyle/>
-          <a:p>
-            <a:r>
-              <a:t>[PRESENTER: Ashis Das (11:30-12:30)]</a:t>
-            </a:r>
-          </a:p>
-          <a:p/>
-          <a:p>
-            <a:r>
-              <a:t>To close: future improvements include probability calibration with an explicit threshold policy, an odd-year model that adds blood pressure and cholesterol, survey-weighted metrics, and SHAP explanations wired into an automated fairness gate. Key risks: recall is low for younger, low-prevalence adults, so the tool must never be used to rule out risk; self-report and selection bias exist in survey data; and scores must not be misused for insurance or discriminatory decisions. Scalability and cost are low because we use batch scoring on modest CPU instances. Thanks for watching — we're happy to take questions.</a:t>
-            </a:r>
-          </a:p>
-        </p:txBody>
-      </p:sp>
-      <p:sp>
-        <p:nvSpPr>
-          <p:cNvPr id="4" name="Slide Number Placeholder 3"/>
-          <p:cNvSpPr>
-            <a:spLocks noGrp="1"/>
-          </p:cNvSpPr>
-          <p:nvPr>
-            <p:ph type="sldNum" idx="5" sz="quarter"/>
-          </p:nvPr>
-        </p:nvSpPr>
-        <p:spPr/>
-      </p:sp>
-    </p:spTree>
-  </p:cSld>
-  <p:clrMapOvr>
-    <a:masterClrMapping/>
-  </p:clrMapOvr>
-</p:notes>
-</file>
-
-<file path=ppt/notesSlides/notesSlide12.xml><?xml version="1.0" encoding="utf-8"?>
-<p:notes xmlns:a="http://schemas.openxmlformats.org/drawingml/2006/main" xmlns:p="http://schemas.openxmlformats.org/presentationml/2006/main" xmlns:r="http://schemas.openxmlformats.org/officeDocument/2006/relationships">
-  <p:cSld>
-    <p:spTree>
-      <p:nvGrpSpPr>
-        <p:cNvPr id="1" name=""/>
-        <p:cNvGrpSpPr/>
-        <p:nvPr/>
-      </p:nvGrpSpPr>
-      <p:grpSpPr>
-        <a:xfrm>
-          <a:off x="0" y="0"/>
-          <a:ext cx="0" cy="0"/>
-          <a:chOff x="0" y="0"/>
-          <a:chExt cx="0" cy="0"/>
-        </a:xfrm>
-      </p:grpSpPr>
-      <p:sp>
-        <p:nvSpPr>
-          <p:cNvPr id="2" name="Slide Image Placeholder 1"/>
-          <p:cNvSpPr>
-            <a:spLocks noGrp="1"/>
-          </p:cNvSpPr>
-          <p:nvPr>
-            <p:ph type="sldImg" idx="2"/>
-          </p:nvPr>
-        </p:nvSpPr>
-        <p:spPr/>
-      </p:sp>
-      <p:sp>
-        <p:nvSpPr>
-          <p:cNvPr id="3" name="Notes Placeholder 2"/>
-          <p:cNvSpPr>
-            <a:spLocks noGrp="1"/>
-          </p:cNvSpPr>
-          <p:nvPr>
-            <p:ph type="body" idx="3" sz="quarter"/>
-          </p:nvPr>
-        </p:nvSpPr>
-        <p:spPr/>
-        <p:txBody>
-          <a:bodyPr/>
-          <a:lstStyle/>
-          <a:p>
-            <a:r>
-              <a:t>[PRESENTER: All]</a:t>
-            </a:r>
-          </a:p>
-          <a:p/>
-          <a:p>
-            <a:r>
-              <a:t>Thank you. Questions welcome. Our GitHub repository link is on this slide and in the design document.</a:t>
-            </a:r>
-          </a:p>
-        </p:txBody>
-      </p:sp>
-      <p:sp>
-        <p:nvSpPr>
-          <p:cNvPr id="4" name="Slide Number Placeholder 3"/>
-          <p:cNvSpPr>
-            <a:spLocks noGrp="1"/>
-          </p:cNvSpPr>
-          <p:nvPr>
-            <p:ph type="sldNum" idx="5" sz="quarter"/>
-          </p:nvPr>
-        </p:nvSpPr>
-        <p:spPr/>
-      </p:sp>
-    </p:spTree>
-  </p:cSld>
-  <p:clrMapOvr>
-    <a:masterClrMapping/>
-  </p:clrMapOvr>
-</p:notes>
-</file>
-
-<file path=ppt/notesSlides/notesSlide2.xml><?xml version="1.0" encoding="utf-8"?>
-<p:notes xmlns:a="http://schemas.openxmlformats.org/drawingml/2006/main" xmlns:p="http://schemas.openxmlformats.org/presentationml/2006/main" xmlns:r="http://schemas.openxmlformats.org/officeDocument/2006/relationships">
-  <p:cSld>
-    <p:spTree>
-      <p:nvGrpSpPr>
-        <p:cNvPr id="1" name=""/>
-        <p:cNvGrpSpPr/>
-        <p:nvPr/>
-      </p:nvGrpSpPr>
-      <p:grpSpPr>
-        <a:xfrm>
-          <a:off x="0" y="0"/>
-          <a:ext cx="0" cy="0"/>
-          <a:chOff x="0" y="0"/>
-          <a:chExt cx="0" cy="0"/>
-        </a:xfrm>
-      </p:grpSpPr>
-      <p:sp>
-        <p:nvSpPr>
-          <p:cNvPr id="2" name="Slide Image Placeholder 1"/>
-          <p:cNvSpPr>
-            <a:spLocks noGrp="1"/>
-          </p:cNvSpPr>
-          <p:nvPr>
-            <p:ph type="sldImg" idx="2"/>
-          </p:nvPr>
-        </p:nvSpPr>
-        <p:spPr/>
-      </p:sp>
-      <p:sp>
-        <p:nvSpPr>
-          <p:cNvPr id="3" name="Notes Placeholder 2"/>
-          <p:cNvSpPr>
-            <a:spLocks noGrp="1"/>
-          </p:cNvSpPr>
-          <p:nvPr>
-            <p:ph type="body" idx="3" sz="quarter"/>
-          </p:nvPr>
-        </p:nvSpPr>
-        <p:spPr/>
-        <p:txBody>
-          <a:bodyPr/>
-          <a:lstStyle/>
-          <a:p>
-            <a:r>
-              <a:t>[PRESENTER: Ashis Das (0:45-1:15)]</a:t>
-            </a:r>
-          </a:p>
-          <a:p/>
-          <a:p>
-            <a:r>
-              <a:t>Here is our running order. We walk through the full MLOps system: the feature store, infrastructure monitoring, model and data monitoring, the CI/CD pipeline in both a successful and a failed state, the model registry, and the batch-inference outputs. We close with future improvements and risks. Each topic is explained on its slide, and the explanation is also in the notes below each slide.</a:t>
-            </a:r>
-          </a:p>
-        </p:txBody>
-      </p:sp>
-      <p:sp>
-        <p:nvSpPr>
-          <p:cNvPr id="4" name="Slide Number Placeholder 3"/>
-          <p:cNvSpPr>
-            <a:spLocks noGrp="1"/>
-          </p:cNvSpPr>
-          <p:nvPr>
-            <p:ph type="sldNum" idx="5" sz="quarter"/>
-          </p:nvPr>
-        </p:nvSpPr>
-        <p:spPr/>
-      </p:sp>
-    </p:spTree>
-  </p:cSld>
-  <p:clrMapOvr>
-    <a:masterClrMapping/>
-  </p:clrMapOvr>
-</p:notes>
-</file>
-
-<file path=ppt/notesSlides/notesSlide3.xml><?xml version="1.0" encoding="utf-8"?>
-<p:notes xmlns:a="http://schemas.openxmlformats.org/drawingml/2006/main" xmlns:p="http://schemas.openxmlformats.org/presentationml/2006/main" xmlns:r="http://schemas.openxmlformats.org/officeDocument/2006/relationships">
-  <p:cSld>
-    <p:spTree>
-      <p:nvGrpSpPr>
-        <p:cNvPr id="1" name=""/>
-        <p:cNvGrpSpPr/>
-        <p:nvPr/>
-      </p:nvGrpSpPr>
-      <p:grpSpPr>
-        <a:xfrm>
-          <a:off x="0" y="0"/>
-          <a:ext cx="0" cy="0"/>
-          <a:chOff x="0" y="0"/>
-          <a:chExt cx="0" cy="0"/>
-        </a:xfrm>
-      </p:grpSpPr>
-      <p:sp>
-        <p:nvSpPr>
-          <p:cNvPr id="2" name="Slide Image Placeholder 1"/>
-          <p:cNvSpPr>
-            <a:spLocks noGrp="1"/>
-          </p:cNvSpPr>
-          <p:nvPr>
-            <p:ph type="sldImg" idx="2"/>
-          </p:nvPr>
-        </p:nvSpPr>
-        <p:spPr/>
-      </p:sp>
-      <p:sp>
-        <p:nvSpPr>
-          <p:cNvPr id="3" name="Notes Placeholder 2"/>
-          <p:cNvSpPr>
-            <a:spLocks noGrp="1"/>
-          </p:cNvSpPr>
-          <p:nvPr>
-            <p:ph type="body" idx="3" sz="quarter"/>
-          </p:nvPr>
-        </p:nvSpPr>
-        <p:spPr/>
-        <p:txBody>
-          <a:bodyPr/>
-          <a:lstStyle/>
-          <a:p>
-            <a:r>
-              <a:t>[PRESENTER: Ashis Das (1:15-2:15)]</a:t>
-            </a:r>
-          </a:p>
-          <a:p/>
-          <a:p>
-            <a:r>
-              <a:t>Our hypothetical stakeholder is a population-health provider that wants to prioritise adults for preventive heart-health outreach. Cardiovascular disease is often silent until a serious event. Using only NON-INVASIVE survey data — demographics, lifestyle and general health — our model flags individuals more likely to have coronary heart disease or a prior heart attack, so limited outreach budget targets the highest-risk people first. This is a screening aid, explicitly NOT a diagnosis. Success is measured by recall on a future year and by lift over a naive baseline.</a:t>
-            </a:r>
-          </a:p>
-        </p:txBody>
-      </p:sp>
-      <p:sp>
-        <p:nvSpPr>
-          <p:cNvPr id="4" name="Slide Number Placeholder 3"/>
-          <p:cNvSpPr>
-            <a:spLocks noGrp="1"/>
-          </p:cNvSpPr>
-          <p:nvPr>
-            <p:ph type="sldNum" idx="5" sz="quarter"/>
-          </p:nvPr>
-        </p:nvSpPr>
-        <p:spPr/>
-      </p:sp>
-    </p:spTree>
-  </p:cSld>
-  <p:clrMapOvr>
-    <a:masterClrMapping/>
-  </p:clrMapOvr>
-</p:notes>
-</file>
-
-<file path=ppt/notesSlides/notesSlide4.xml><?xml version="1.0" encoding="utf-8"?>
-<p:notes xmlns:a="http://schemas.openxmlformats.org/drawingml/2006/main" xmlns:p="http://schemas.openxmlformats.org/presentationml/2006/main" xmlns:r="http://schemas.openxmlformats.org/officeDocument/2006/relationships">
-  <p:cSld>
-    <p:spTree>
-      <p:nvGrpSpPr>
-        <p:cNvPr id="1" name=""/>
-        <p:cNvGrpSpPr/>
-        <p:nvPr/>
-      </p:nvGrpSpPr>
-      <p:grpSpPr>
-        <a:xfrm>
-          <a:off x="0" y="0"/>
-          <a:ext cx="0" cy="0"/>
-          <a:chOff x="0" y="0"/>
-          <a:chExt cx="0" cy="0"/>
-        </a:xfrm>
-      </p:grpSpPr>
-      <p:sp>
-        <p:nvSpPr>
-          <p:cNvPr id="2" name="Slide Image Placeholder 1"/>
-          <p:cNvSpPr>
-            <a:spLocks noGrp="1"/>
-          </p:cNvSpPr>
-          <p:nvPr>
-            <p:ph type="sldImg" idx="2"/>
-          </p:nvPr>
-        </p:nvSpPr>
-        <p:spPr/>
-      </p:sp>
-      <p:sp>
-        <p:nvSpPr>
-          <p:cNvPr id="3" name="Notes Placeholder 2"/>
-          <p:cNvSpPr>
-            <a:spLocks noGrp="1"/>
-          </p:cNvSpPr>
-          <p:nvPr>
-            <p:ph type="body" idx="3" sz="quarter"/>
-          </p:nvPr>
-        </p:nvSpPr>
-        <p:spPr/>
-        <p:txBody>
-          <a:bodyPr/>
-          <a:lstStyle/>
-          <a:p>
-            <a:r>
-              <a:t>[PRESENTER: Ashis Das (2:15-3:30)]</a:t>
-            </a:r>
-          </a:p>
-          <a:p/>
-          <a:p>
-            <a:r>
-              <a:t>Here's the end-to-end architecture. Raw BRFSS XPT files land in an S3 raw bucket. A SageMaker processing job harmonises them into parquet in a curated bucket and ingests features into SageMaker Feature Store. A SageMaker Pipeline orchestrates processing, training, an evaluation gate, and model registration into the Model Registry. Approved models run as Batch Transform jobs. Model Monitor and CloudWatch watch data quality, model quality and infrastructure. Every topic in this talk corresponds to a box on this diagram. One important note on scope: this architecture is designed for AWS SageMaker. Because AWS access was not available to us, we present each component as a design, and we implemented and validated the same pipeline logic locally — so the results and artifacts are real even though the managed services are presented as the intended design. For each component we explain the SageMaker service and the local implementation that backs it. I'll now hand over to Hanmant for the feature store.</a:t>
-            </a:r>
-          </a:p>
-        </p:txBody>
-      </p:sp>
-      <p:sp>
-        <p:nvSpPr>
-          <p:cNvPr id="4" name="Slide Number Placeholder 3"/>
-          <p:cNvSpPr>
-            <a:spLocks noGrp="1"/>
-          </p:cNvSpPr>
-          <p:nvPr>
-            <p:ph type="sldNum" idx="5" sz="quarter"/>
-          </p:nvPr>
-        </p:nvSpPr>
-        <p:spPr/>
-      </p:sp>
-    </p:spTree>
-  </p:cSld>
-  <p:clrMapOvr>
-    <a:masterClrMapping/>
-  </p:clrMapOvr>
-</p:notes>
-</file>
-
-<file path=ppt/notesSlides/notesSlide5.xml><?xml version="1.0" encoding="utf-8"?>
-<p:notes xmlns:a="http://schemas.openxmlformats.org/drawingml/2006/main" xmlns:p="http://schemas.openxmlformats.org/presentationml/2006/main" xmlns:r="http://schemas.openxmlformats.org/officeDocument/2006/relationships">
-  <p:cSld>
-    <p:spTree>
-      <p:nvGrpSpPr>
-        <p:cNvPr id="1" name=""/>
-        <p:cNvGrpSpPr/>
-        <p:nvPr/>
-      </p:nvGrpSpPr>
-      <p:grpSpPr>
-        <a:xfrm>
-          <a:off x="0" y="0"/>
-          <a:ext cx="0" cy="0"/>
-          <a:chOff x="0" y="0"/>
-          <a:chExt cx="0" cy="0"/>
-        </a:xfrm>
-      </p:grpSpPr>
-      <p:sp>
-        <p:nvSpPr>
-          <p:cNvPr id="2" name="Slide Image Placeholder 1"/>
-          <p:cNvSpPr>
-            <a:spLocks noGrp="1"/>
-          </p:cNvSpPr>
-          <p:nvPr>
-            <p:ph type="sldImg" idx="2"/>
-          </p:nvPr>
-        </p:nvSpPr>
-        <p:spPr/>
-      </p:sp>
-      <p:sp>
-        <p:nvSpPr>
-          <p:cNvPr id="3" name="Notes Placeholder 2"/>
-          <p:cNvSpPr>
-            <a:spLocks noGrp="1"/>
-          </p:cNvSpPr>
-          <p:nvPr>
-            <p:ph type="body" idx="3" sz="quarter"/>
-          </p:nvPr>
-        </p:nvSpPr>
-        <p:spPr/>
-        <p:txBody>
-          <a:bodyPr/>
-          <a:lstStyle/>
-          <a:p>
-            <a:r>
-              <a:t>[PRESENTER: Hanmant Mhalappa Kattimani (3:30-5:00)]</a:t>
-            </a:r>
-          </a:p>
-          <a:p/>
-          <a:p>
-            <a:r>
-              <a:t>This is our feature foundation. In the SageMaker design this is a Feature Store feature group; here we demonstrate the equivalent as the harmonised feature set we build and persist locally. It holds the 15 variables common to all three BRFSS years. It has three continuous features — BMI, poor mental-health days and poor physical-health days — and twelve categorical survey codes such as age band, sex, general health, smoker status, diabetes and difficulty walking. The three target-defining columns (CVDINFR4, CVDCRHD4 and _MICHD) are deliberately kept out to prevent leakage. Because both training and inference read from this same feature set, the features seen at inference are identical to those seen in training — that is how we guarantee train/serve consistency.</a:t>
-            </a:r>
-          </a:p>
-        </p:txBody>
-      </p:sp>
-      <p:sp>
-        <p:nvSpPr>
-          <p:cNvPr id="4" name="Slide Number Placeholder 3"/>
-          <p:cNvSpPr>
-            <a:spLocks noGrp="1"/>
-          </p:cNvSpPr>
-          <p:nvPr>
-            <p:ph type="sldNum" idx="5" sz="quarter"/>
-          </p:nvPr>
-        </p:nvSpPr>
-        <p:spPr/>
-      </p:sp>
-    </p:spTree>
-  </p:cSld>
-  <p:clrMapOvr>
-    <a:masterClrMapping/>
-  </p:clrMapOvr>
-</p:notes>
-</file>
-
-<file path=ppt/notesSlides/notesSlide6.xml><?xml version="1.0" encoding="utf-8"?>
-<p:notes xmlns:a="http://schemas.openxmlformats.org/drawingml/2006/main" xmlns:p="http://schemas.openxmlformats.org/presentationml/2006/main" xmlns:r="http://schemas.openxmlformats.org/officeDocument/2006/relationships">
-  <p:cSld>
-    <p:spTree>
-      <p:nvGrpSpPr>
-        <p:cNvPr id="1" name=""/>
-        <p:cNvGrpSpPr/>
-        <p:nvPr/>
-      </p:nvGrpSpPr>
-      <p:grpSpPr>
-        <a:xfrm>
-          <a:off x="0" y="0"/>
-          <a:ext cx="0" cy="0"/>
-          <a:chOff x="0" y="0"/>
-          <a:chExt cx="0" cy="0"/>
-        </a:xfrm>
-      </p:grpSpPr>
-      <p:sp>
-        <p:nvSpPr>
-          <p:cNvPr id="2" name="Slide Image Placeholder 1"/>
-          <p:cNvSpPr>
-            <a:spLocks noGrp="1"/>
-          </p:cNvSpPr>
-          <p:nvPr>
-            <p:ph type="sldImg" idx="2"/>
-          </p:nvPr>
-        </p:nvSpPr>
-        <p:spPr/>
-      </p:sp>
-      <p:sp>
-        <p:nvSpPr>
-          <p:cNvPr id="3" name="Notes Placeholder 2"/>
-          <p:cNvSpPr>
-            <a:spLocks noGrp="1"/>
-          </p:cNvSpPr>
-          <p:nvPr>
-            <p:ph type="body" idx="3" sz="quarter"/>
-          </p:nvPr>
-        </p:nvSpPr>
-        <p:spPr/>
-        <p:txBody>
-          <a:bodyPr/>
-          <a:lstStyle/>
-          <a:p>
-            <a:r>
-              <a:t>[PRESENTER: Hanmant Mhalappa Kattimani (5:00-6:15)]</a:t>
-            </a:r>
-          </a:p>
-          <a:p/>
-          <a:p>
-            <a:r>
-              <a:t>In the SageMaker design, infrastructure is monitored with CloudWatch dashboards and alarms; here we show the equivalent using our local job logs and run status. The design tracks whether each job succeeded or failed, how long each stage ran, CPU and memory utilisation on the ml.m5.large instances, and error and invocation counts, with alarms so that if a batch job fails or runs longer than its expected window, the team is notified automatically. The point of this layer is operational confidence: it tells the on-call engineer whether the pipeline ran cleanly in each screening cycle, regardless of how the model itself is performing.</a:t>
-            </a:r>
-          </a:p>
-        </p:txBody>
-      </p:sp>
-      <p:sp>
-        <p:nvSpPr>
-          <p:cNvPr id="4" name="Slide Number Placeholder 3"/>
-          <p:cNvSpPr>
-            <a:spLocks noGrp="1"/>
-          </p:cNvSpPr>
-          <p:nvPr>
-            <p:ph type="sldNum" idx="5" sz="quarter"/>
-          </p:nvPr>
-        </p:nvSpPr>
-        <p:spPr/>
-      </p:sp>
-    </p:spTree>
-  </p:cSld>
-  <p:clrMapOvr>
-    <a:masterClrMapping/>
-  </p:clrMapOvr>
-</p:notes>
-</file>
-
-<file path=ppt/notesSlides/notesSlide7.xml><?xml version="1.0" encoding="utf-8"?>
-<p:notes xmlns:a="http://schemas.openxmlformats.org/drawingml/2006/main" xmlns:p="http://schemas.openxmlformats.org/presentationml/2006/main" xmlns:r="http://schemas.openxmlformats.org/officeDocument/2006/relationships">
-  <p:cSld>
-    <p:spTree>
-      <p:nvGrpSpPr>
-        <p:cNvPr id="1" name=""/>
-        <p:cNvGrpSpPr/>
-        <p:nvPr/>
-      </p:nvGrpSpPr>
-      <p:grpSpPr>
-        <a:xfrm>
-          <a:off x="0" y="0"/>
-          <a:ext cx="0" cy="0"/>
-          <a:chOff x="0" y="0"/>
-          <a:chExt cx="0" cy="0"/>
-        </a:xfrm>
-      </p:grpSpPr>
-      <p:sp>
-        <p:nvSpPr>
-          <p:cNvPr id="2" name="Slide Image Placeholder 1"/>
-          <p:cNvSpPr>
-            <a:spLocks noGrp="1"/>
-          </p:cNvSpPr>
-          <p:nvPr>
-            <p:ph type="sldImg" idx="2"/>
-          </p:nvPr>
-        </p:nvSpPr>
-        <p:spPr/>
-      </p:sp>
-      <p:sp>
-        <p:nvSpPr>
-          <p:cNvPr id="3" name="Notes Placeholder 2"/>
-          <p:cNvSpPr>
-            <a:spLocks noGrp="1"/>
-          </p:cNvSpPr>
-          <p:nvPr>
-            <p:ph type="body" idx="3" sz="quarter"/>
-          </p:nvPr>
-        </p:nvSpPr>
-        <p:spPr/>
-        <p:txBody>
-          <a:bodyPr/>
-          <a:lstStyle/>
-          <a:p>
-            <a:r>
-              <a:t>[PRESENTER: Ram Prasanth G (6:15-7:45)]</a:t>
-            </a:r>
-          </a:p>
-          <a:p/>
-          <a:p>
-            <a:r>
-              <a:t>In the SageMaker design, model and data monitoring run through Model Monitor; here we show the equivalent reports we generate locally. We monitor three things after release. For model quality we track recall, PR-AUC and calibration against an agreed floor and alert if sensitivity drops. For data quality we watch feature distributions and missingness against the training baseline using a population-stability index, so drift is caught before it degrades the model. And for fairness we recompute subgroup recall by sex and age every cycle. The two charts on this slide are our actual outputs: the precision-recall curve on the left shows strong ranking of the rare positive class, and the subgroup chart on the right shows the performance gaps we explicitly track — higher recall for males and older adults, and low recall for younger adults whose prevalence is only about one percent.</a:t>
-            </a:r>
-          </a:p>
-        </p:txBody>
-      </p:sp>
-      <p:sp>
-        <p:nvSpPr>
-          <p:cNvPr id="4" name="Slide Number Placeholder 3"/>
-          <p:cNvSpPr>
-            <a:spLocks noGrp="1"/>
-          </p:cNvSpPr>
-          <p:nvPr>
-            <p:ph type="sldNum" idx="5" sz="quarter"/>
-          </p:nvPr>
-        </p:nvSpPr>
-        <p:spPr/>
-      </p:sp>
-    </p:spTree>
-  </p:cSld>
-  <p:clrMapOvr>
-    <a:masterClrMapping/>
-  </p:clrMapOvr>
-</p:notes>
-</file>
-
-<file path=ppt/notesSlides/notesSlide8.xml><?xml version="1.0" encoding="utf-8"?>
-<p:notes xmlns:a="http://schemas.openxmlformats.org/drawingml/2006/main" xmlns:p="http://schemas.openxmlformats.org/presentationml/2006/main" xmlns:r="http://schemas.openxmlformats.org/officeDocument/2006/relationships">
-  <p:cSld>
-    <p:spTree>
-      <p:nvGrpSpPr>
-        <p:cNvPr id="1" name=""/>
-        <p:cNvGrpSpPr/>
-        <p:nvPr/>
-      </p:nvGrpSpPr>
-      <p:grpSpPr>
-        <a:xfrm>
-          <a:off x="0" y="0"/>
-          <a:ext cx="0" cy="0"/>
-          <a:chOff x="0" y="0"/>
-          <a:chExt cx="0" cy="0"/>
-        </a:xfrm>
-      </p:grpSpPr>
-      <p:sp>
-        <p:nvSpPr>
-          <p:cNvPr id="2" name="Slide Image Placeholder 1"/>
-          <p:cNvSpPr>
-            <a:spLocks noGrp="1"/>
-          </p:cNvSpPr>
-          <p:nvPr>
-            <p:ph type="sldImg" idx="2"/>
-          </p:nvPr>
-        </p:nvSpPr>
-        <p:spPr/>
-      </p:sp>
-      <p:sp>
-        <p:nvSpPr>
-          <p:cNvPr id="3" name="Notes Placeholder 2"/>
-          <p:cNvSpPr>
-            <a:spLocks noGrp="1"/>
-          </p:cNvSpPr>
-          <p:nvPr>
-            <p:ph type="body" idx="3" sz="quarter"/>
-          </p:nvPr>
-        </p:nvSpPr>
-        <p:spPr/>
-        <p:txBody>
-          <a:bodyPr/>
-          <a:lstStyle/>
-          <a:p>
-            <a:r>
-              <a:t>[PRESENTER: Hanmant Mhalappa Kattimani (7:45-9:15)]</a:t>
-            </a:r>
-          </a:p>
-          <a:p/>
-          <a:p>
-            <a:r>
-              <a:t>In the SageMaker design this is a SageMaker Pipeline; here we demonstrate the equivalent with our local pipeline logic and test gate. The pipeline is a directed graph of stages: schema validation, processing, feature ingest, training, an evaluation gate, model registration, and batch scoring. The left column shows a successful run — every stage passes and the model is registered. The right column shows a failed run that is stopped at the evaluation gate: if the candidate's PR-AUC or recall falls below the current production model, or a required variable is missing for a year, the gate fails and the later stages never run, so a worse model can never be promoted. Our automated test suite — leakage, data-contract, temporal-split and preprocessor checks — runs as the very first step and currently passes five out of five.</a:t>
-            </a:r>
-          </a:p>
-        </p:txBody>
-      </p:sp>
-      <p:sp>
-        <p:nvSpPr>
-          <p:cNvPr id="4" name="Slide Number Placeholder 3"/>
-          <p:cNvSpPr>
-            <a:spLocks noGrp="1"/>
-          </p:cNvSpPr>
-          <p:nvPr>
-            <p:ph type="sldNum" idx="5" sz="quarter"/>
-          </p:nvPr>
-        </p:nvSpPr>
-        <p:spPr/>
-      </p:sp>
-    </p:spTree>
-  </p:cSld>
-  <p:clrMapOvr>
-    <a:masterClrMapping/>
-  </p:clrMapOvr>
-</p:notes>
-</file>
-
-<file path=ppt/notesSlides/notesSlide9.xml><?xml version="1.0" encoding="utf-8"?>
-<p:notes xmlns:a="http://schemas.openxmlformats.org/drawingml/2006/main" xmlns:p="http://schemas.openxmlformats.org/presentationml/2006/main" xmlns:r="http://schemas.openxmlformats.org/officeDocument/2006/relationships">
-  <p:cSld>
-    <p:spTree>
-      <p:nvGrpSpPr>
-        <p:cNvPr id="1" name=""/>
-        <p:cNvGrpSpPr/>
-        <p:nvPr/>
-      </p:nvGrpSpPr>
-      <p:grpSpPr>
-        <a:xfrm>
-          <a:off x="0" y="0"/>
-          <a:ext cx="0" cy="0"/>
-          <a:chOff x="0" y="0"/>
-          <a:chExt cx="0" cy="0"/>
-        </a:xfrm>
-      </p:grpSpPr>
-      <p:sp>
-        <p:nvSpPr>
-          <p:cNvPr id="2" name="Slide Image Placeholder 1"/>
-          <p:cNvSpPr>
-            <a:spLocks noGrp="1"/>
-          </p:cNvSpPr>
-          <p:nvPr>
-            <p:ph type="sldImg" idx="2"/>
-          </p:nvPr>
-        </p:nvSpPr>
-        <p:spPr/>
-      </p:sp>
-      <p:sp>
-        <p:nvSpPr>
-          <p:cNvPr id="3" name="Notes Placeholder 2"/>
-          <p:cNvSpPr>
-            <a:spLocks noGrp="1"/>
-          </p:cNvSpPr>
-          <p:nvPr>
-            <p:ph type="body" idx="3" sz="quarter"/>
-          </p:nvPr>
-        </p:nvSpPr>
-        <p:spPr/>
-        <p:txBody>
-          <a:bodyPr/>
-          <a:lstStyle/>
-          <a:p>
-            <a:r>
-              <a:t>[PRESENTER: Ram Prasanth G (9:15-10:15)]</a:t>
-            </a:r>
-          </a:p>
-          <a:p/>
-          <a:p>
-            <a:r>
-              <a:t>In the SageMaker design this is the Model Registry; here we demonstrate the equivalent with our saved model artifact and its metadata. Every model that passes the evaluation gate is recorded as a version together with the metrics it was approved on. Our selected version is XGBoost, recorded with a PR-AUC of 0.321 and recall of 0.819, and marked approved. Only an approved version is eligible for batch deployment, which gives us governance over what reaches production. The metadata also records lineage — from the data and features through training to the model artifact — so we can audit any prediction and roll back to a previous approved version if a new one misbehaves.</a:t>
-            </a:r>
-          </a:p>
-        </p:txBody>
-      </p:sp>
-      <p:sp>
-        <p:nvSpPr>
-          <p:cNvPr id="4" name="Slide Number Placeholder 3"/>
-          <p:cNvSpPr>
-            <a:spLocks noGrp="1"/>
-          </p:cNvSpPr>
-          <p:nvPr>
-            <p:ph type="sldNum" idx="5" sz="quarter"/>
-          </p:nvPr>
-        </p:nvSpPr>
-        <p:spPr/>
-      </p:sp>
-    </p:spTree>
-  </p:cSld>
-  <p:clrMapOvr>
-    <a:masterClrMapping/>
-  </p:clrMapOvr>
-</p:notes>
 </file>
 
 <file path=ppt/slideLayouts/slideLayout1.xml><?xml version="1.0" encoding="utf-8"?>
@@ -4716,7 +3454,7 @@
           <p:nvPr/>
         </p:nvPicPr>
         <p:blipFill>
-          <a:blip r:embed="rId3"/>
+          <a:blip r:embed="rId2"/>
           <a:stretch>
             <a:fillRect/>
           </a:stretch>
@@ -7960,7 +6698,7 @@
           <p:nvPr/>
         </p:nvPicPr>
         <p:blipFill>
-          <a:blip r:embed="rId3"/>
+          <a:blip r:embed="rId2"/>
           <a:stretch>
             <a:fillRect/>
           </a:stretch>
@@ -7984,7 +6722,7 @@
           <p:nvPr/>
         </p:nvPicPr>
         <p:blipFill>
-          <a:blip r:embed="rId4"/>
+          <a:blip r:embed="rId3"/>
           <a:stretch>
             <a:fillRect/>
           </a:stretch>
@@ -9742,324 +8480,4 @@
   </a:objectDefaults>
   <a:extraClrSchemeLst/>
 </a:theme>
-</file>
-
-<file path=ppt/theme/theme2.xml><?xml version="1.0" encoding="utf-8"?>
-<a:theme xmlns:a="http://schemas.openxmlformats.org/drawingml/2006/main" name="Office Theme">
-  <a:themeElements>
-    <a:clrScheme name="Office">
-      <a:dk1>
-        <a:sysClr val="windowText" lastClr="000000"/>
-      </a:dk1>
-      <a:lt1>
-        <a:sysClr val="window" lastClr="FFFFFF"/>
-      </a:lt1>
-      <a:dk2>
-        <a:srgbClr val="1F497D"/>
-      </a:dk2>
-      <a:lt2>
-        <a:srgbClr val="EEECE1"/>
-      </a:lt2>
-      <a:accent1>
-        <a:srgbClr val="4F81BD"/>
-      </a:accent1>
-      <a:accent2>
-        <a:srgbClr val="C0504D"/>
-      </a:accent2>
-      <a:accent3>
-        <a:srgbClr val="9BBB59"/>
-      </a:accent3>
-      <a:accent4>
-        <a:srgbClr val="8064A2"/>
-      </a:accent4>
-      <a:accent5>
-        <a:srgbClr val="4BACC6"/>
-      </a:accent5>
-      <a:accent6>
-        <a:srgbClr val="F79646"/>
-      </a:accent6>
-      <a:hlink>
-        <a:srgbClr val="0000FF"/>
-      </a:hlink>
-      <a:folHlink>
-        <a:srgbClr val="800080"/>
-      </a:folHlink>
-    </a:clrScheme>
-    <a:fontScheme name="Office">
-      <a:majorFont>
-        <a:latin typeface="Calibri"/>
-        <a:ea typeface=""/>
-        <a:cs typeface=""/>
-        <a:font script="Jpan" typeface="ＭＳ Ｐゴシック"/>
-        <a:font script="Hang" typeface="맑은 고딕"/>
-        <a:font script="Hans" typeface="宋体"/>
-        <a:font script="Hant" typeface="新細明體"/>
-        <a:font script="Arab" typeface="Times New Roman"/>
-        <a:font script="Hebr" typeface="Times New Roman"/>
-        <a:font script="Thai" typeface="Angsana New"/>
-        <a:font script="Ethi" typeface="Nyala"/>
-        <a:font script="Beng" typeface="Vrinda"/>
-        <a:font script="Gujr" typeface="Shruti"/>
-        <a:font script="Khmr" typeface="MoolBoran"/>
-        <a:font script="Knda" typeface="Tunga"/>
-        <a:font script="Guru" typeface="Raavi"/>
-        <a:font script="Cans" typeface="Euphemia"/>
-        <a:font script="Cher" typeface="Plantagenet Cherokee"/>
-        <a:font script="Yiii" typeface="Microsoft Yi Baiti"/>
-        <a:font script="Tibt" typeface="Microsoft Himalaya"/>
-        <a:font script="Thaa" typeface="MV Boli"/>
-        <a:font script="Deva" typeface="Mangal"/>
-        <a:font script="Telu" typeface="Gautami"/>
-        <a:font script="Taml" typeface="Latha"/>
-        <a:font script="Syrc" typeface="Estrangelo Edessa"/>
-        <a:font script="Orya" typeface="Kalinga"/>
-        <a:font script="Mlym" typeface="Kartika"/>
-        <a:font script="Laoo" typeface="DokChampa"/>
-        <a:font script="Sinh" typeface="Iskoola Pota"/>
-        <a:font script="Mong" typeface="Mongolian Baiti"/>
-        <a:font script="Viet" typeface="Times New Roman"/>
-        <a:font script="Uigh" typeface="Microsoft Uighur"/>
-        <a:font script="Geor" typeface="Sylfaen"/>
-      </a:majorFont>
-      <a:minorFont>
-        <a:latin typeface="Calibri"/>
-        <a:ea typeface=""/>
-        <a:cs typeface=""/>
-        <a:font script="Jpan" typeface="ＭＳ Ｐゴシック"/>
-        <a:font script="Hang" typeface="맑은 고딕"/>
-        <a:font script="Hans" typeface="宋体"/>
-        <a:font script="Hant" typeface="新細明體"/>
-        <a:font script="Arab" typeface="Arial"/>
-        <a:font script="Hebr" typeface="Arial"/>
-        <a:font script="Thai" typeface="Cordia New"/>
-        <a:font script="Ethi" typeface="Nyala"/>
-        <a:font script="Beng" typeface="Vrinda"/>
-        <a:font script="Gujr" typeface="Shruti"/>
-        <a:font script="Khmr" typeface="DaunPenh"/>
-        <a:font script="Knda" typeface="Tunga"/>
-        <a:font script="Guru" typeface="Raavi"/>
-        <a:font script="Cans" typeface="Euphemia"/>
-        <a:font script="Cher" typeface="Plantagenet Cherokee"/>
-        <a:font script="Yiii" typeface="Microsoft Yi Baiti"/>
-        <a:font script="Tibt" typeface="Microsoft Himalaya"/>
-        <a:font script="Thaa" typeface="MV Boli"/>
-        <a:font script="Deva" typeface="Mangal"/>
-        <a:font script="Telu" typeface="Gautami"/>
-        <a:font script="Taml" typeface="Latha"/>
-        <a:font script="Syrc" typeface="Estrangelo Edessa"/>
-        <a:font script="Orya" typeface="Kalinga"/>
-        <a:font script="Mlym" typeface="Kartika"/>
-        <a:font script="Laoo" typeface="DokChampa"/>
-        <a:font script="Sinh" typeface="Iskoola Pota"/>
-        <a:font script="Mong" typeface="Mongolian Baiti"/>
-        <a:font script="Viet" typeface="Arial"/>
-        <a:font script="Uigh" typeface="Microsoft Uighur"/>
-        <a:font script="Geor" typeface="Sylfaen"/>
-      </a:minorFont>
-    </a:fontScheme>
-    <a:fmtScheme name="Office">
-      <a:fillStyleLst>
-        <a:solidFill>
-          <a:schemeClr val="phClr"/>
-        </a:solidFill>
-        <a:gradFill rotWithShape="1">
-          <a:gsLst>
-            <a:gs pos="0">
-              <a:schemeClr val="phClr">
-                <a:tint val="50000"/>
-                <a:satMod val="300000"/>
-              </a:schemeClr>
-            </a:gs>
-            <a:gs pos="35000">
-              <a:schemeClr val="phClr">
-                <a:tint val="37000"/>
-                <a:satMod val="300000"/>
-              </a:schemeClr>
-            </a:gs>
-            <a:gs pos="100000">
-              <a:schemeClr val="phClr">
-                <a:tint val="15000"/>
-                <a:satMod val="350000"/>
-              </a:schemeClr>
-            </a:gs>
-          </a:gsLst>
-          <a:lin ang="16200000" scaled="1"/>
-        </a:gradFill>
-        <a:gradFill rotWithShape="1">
-          <a:gsLst>
-            <a:gs pos="0">
-              <a:schemeClr val="phClr">
-                <a:tint val="100000"/>
-                <a:shade val="100000"/>
-                <a:satMod val="130000"/>
-              </a:schemeClr>
-            </a:gs>
-            <a:gs pos="100000">
-              <a:schemeClr val="phClr">
-                <a:tint val="50000"/>
-                <a:shade val="100000"/>
-                <a:satMod val="350000"/>
-              </a:schemeClr>
-            </a:gs>
-          </a:gsLst>
-          <a:lin ang="16200000" scaled="0"/>
-        </a:gradFill>
-      </a:fillStyleLst>
-      <a:lnStyleLst>
-        <a:ln w="9525" cap="flat" cmpd="sng" algn="ctr">
-          <a:solidFill>
-            <a:schemeClr val="phClr">
-              <a:shade val="95000"/>
-              <a:satMod val="105000"/>
-            </a:schemeClr>
-          </a:solidFill>
-          <a:prstDash val="solid"/>
-        </a:ln>
-        <a:ln w="25400" cap="flat" cmpd="sng" algn="ctr">
-          <a:solidFill>
-            <a:schemeClr val="phClr"/>
-          </a:solidFill>
-          <a:prstDash val="solid"/>
-        </a:ln>
-        <a:ln w="38100" cap="flat" cmpd="sng" algn="ctr">
-          <a:solidFill>
-            <a:schemeClr val="phClr"/>
-          </a:solidFill>
-          <a:prstDash val="solid"/>
-        </a:ln>
-      </a:lnStyleLst>
-      <a:effectStyleLst>
-        <a:effectStyle>
-          <a:effectLst>
-            <a:outerShdw blurRad="40000" dist="20000" dir="5400000" rotWithShape="0">
-              <a:srgbClr val="000000">
-                <a:alpha val="38000"/>
-              </a:srgbClr>
-            </a:outerShdw>
-          </a:effectLst>
-        </a:effectStyle>
-        <a:effectStyle>
-          <a:effectLst>
-            <a:outerShdw blurRad="40000" dist="23000" dir="5400000" rotWithShape="0">
-              <a:srgbClr val="000000">
-                <a:alpha val="35000"/>
-              </a:srgbClr>
-            </a:outerShdw>
-          </a:effectLst>
-        </a:effectStyle>
-        <a:effectStyle>
-          <a:effectLst>
-            <a:outerShdw blurRad="40000" dist="23000" dir="5400000" rotWithShape="0">
-              <a:srgbClr val="000000">
-                <a:alpha val="35000"/>
-              </a:srgbClr>
-            </a:outerShdw>
-          </a:effectLst>
-          <a:scene3d>
-            <a:camera prst="orthographicFront">
-              <a:rot lat="0" lon="0" rev="0"/>
-            </a:camera>
-            <a:lightRig rig="threePt" dir="t">
-              <a:rot lat="0" lon="0" rev="1200000"/>
-            </a:lightRig>
-          </a:scene3d>
-          <a:sp3d>
-            <a:bevelT w="63500" h="25400"/>
-          </a:sp3d>
-        </a:effectStyle>
-      </a:effectStyleLst>
-      <a:bgFillStyleLst>
-        <a:solidFill>
-          <a:schemeClr val="phClr"/>
-        </a:solidFill>
-        <a:gradFill rotWithShape="1">
-          <a:gsLst>
-            <a:gs pos="0">
-              <a:schemeClr val="phClr">
-                <a:tint val="40000"/>
-                <a:satMod val="350000"/>
-              </a:schemeClr>
-            </a:gs>
-            <a:gs pos="40000">
-              <a:schemeClr val="phClr">
-                <a:tint val="45000"/>
-                <a:shade val="99000"/>
-                <a:satMod val="350000"/>
-              </a:schemeClr>
-            </a:gs>
-            <a:gs pos="100000">
-              <a:schemeClr val="phClr">
-                <a:shade val="20000"/>
-                <a:satMod val="255000"/>
-              </a:schemeClr>
-            </a:gs>
-          </a:gsLst>
-          <a:path path="circle">
-            <a:fillToRect l="50000" t="-80000" r="50000" b="180000"/>
-          </a:path>
-        </a:gradFill>
-        <a:gradFill rotWithShape="1">
-          <a:gsLst>
-            <a:gs pos="0">
-              <a:schemeClr val="phClr">
-                <a:tint val="80000"/>
-                <a:satMod val="300000"/>
-              </a:schemeClr>
-            </a:gs>
-            <a:gs pos="100000">
-              <a:schemeClr val="phClr">
-                <a:shade val="30000"/>
-                <a:satMod val="200000"/>
-              </a:schemeClr>
-            </a:gs>
-          </a:gsLst>
-          <a:path path="circle">
-            <a:fillToRect l="50000" t="50000" r="50000" b="50000"/>
-          </a:path>
-        </a:gradFill>
-      </a:bgFillStyleLst>
-    </a:fmtScheme>
-  </a:themeElements>
-  <a:objectDefaults>
-    <a:spDef>
-      <a:spPr/>
-      <a:bodyPr/>
-      <a:lstStyle/>
-      <a:style>
-        <a:lnRef idx="1">
-          <a:schemeClr val="accent1"/>
-        </a:lnRef>
-        <a:fillRef idx="3">
-          <a:schemeClr val="accent1"/>
-        </a:fillRef>
-        <a:effectRef idx="2">
-          <a:schemeClr val="accent1"/>
-        </a:effectRef>
-        <a:fontRef idx="minor">
-          <a:schemeClr val="lt1"/>
-        </a:fontRef>
-      </a:style>
-    </a:spDef>
-    <a:lnDef>
-      <a:spPr/>
-      <a:bodyPr/>
-      <a:lstStyle/>
-      <a:style>
-        <a:lnRef idx="2">
-          <a:schemeClr val="accent1"/>
-        </a:lnRef>
-        <a:fillRef idx="0">
-          <a:schemeClr val="accent1"/>
-        </a:fillRef>
-        <a:effectRef idx="1">
-          <a:schemeClr val="accent1"/>
-        </a:effectRef>
-        <a:fontRef idx="minor">
-          <a:schemeClr val="tx1"/>
-        </a:fontRef>
-      </a:style>
-    </a:lnDef>
-  </a:objectDefaults>
-  <a:extraClrSchemeLst/>
-</a:theme>
 </file>
</xml_diff>